<commit_message>
PPTX: Trichter-Begriffe konsistent (Mails -> BUe-Mails -> Vorgaenge)
- Slide 1: 4.000 wird durchgaengig als 'BUe-Anfrage-Mails' bezeichnet
  (vorher uneindeutig 'echte Neue BUe' - der Begriff Vorgang ist Slide 2)
- Slide 1 Subtitel: Trichter explizit '5034 -> 4000 BUe-Mails ->
  Konsolidierung zu Vorgaengen siehe Slide 2'
- Slide 1 Sparten-Donut: 52%/Komposit-Overlay verkleinert, keine
  Ueberlagerung mehr mit dem Donut-Ring
- Slide 2 Titel: 'Von Mails zu Vorgaengen - und wer die Mails schickt';
  Subtitel verweist explizit auf die 4000 aus Slide 1
- Slide 2 Bar-Chart: JDC jetzt sichtbar (Reihenfolge umgedreht -> JDC oben,
  Top-3 dunkel hervorgehoben; gap_width 50 -> 40 fuer mehr Balkenflaeche)

https://claude.ai/code/session_01UknXtYp2XECsQDonCZuxSt
</commit_message>
<xml_diff>
--- a/ERGO-Mengengeruest-2Slides.pptx
+++ b/ERGO-Mengengeruest-2Slides.pptx
@@ -177,7 +177,7 @@
               <c:strCache>
                 <c:ptCount val="3"/>
                 <c:pt idx="0">
-                  <c:v>Neue BUe (4.000)</c:v>
+                  <c:v>BUe-Anfrage-Mails (4.000)</c:v>
                 </c:pt>
                 <c:pt idx="1">
                   <c:v>Keine BUe (705)</c:v>
@@ -463,7 +463,7 @@
               <c:strCache>
                 <c:ptCount val="1"/>
                 <c:pt idx="0">
-                  <c:v>Neue BUe</c:v>
+                  <c:v>BUe-Mails</c:v>
                 </c:pt>
               </c:strCache>
             </c:strRef>
@@ -474,7 +474,7 @@
             </a:solidFill>
           </c:spPr>
           <c:dPt>
-            <c:idx val="0"/>
+            <c:idx val="9"/>
             <c:spPr>
               <a:solidFill>
                 <a:srgbClr val="8E0A20"/>
@@ -482,7 +482,7 @@
             </c:spPr>
           </c:dPt>
           <c:dPt>
-            <c:idx val="1"/>
+            <c:idx val="8"/>
             <c:spPr>
               <a:solidFill>
                 <a:srgbClr val="8E0A20"/>
@@ -490,7 +490,7 @@
             </c:spPr>
           </c:dPt>
           <c:dPt>
-            <c:idx val="2"/>
+            <c:idx val="7"/>
             <c:spPr>
               <a:solidFill>
                 <a:srgbClr val="8E0A20"/>
@@ -503,34 +503,34 @@
               <c:strCache>
                 <c:ptCount val="10"/>
                 <c:pt idx="0">
-                  <c:v>JDC / Jung, DMS &amp; Cie.</c:v>
+                  <c:v>Concordia</c:v>
                 </c:pt>
                 <c:pt idx="1">
+                  <c:v>Securess</c:v>
+                </c:pt>
+                <c:pt idx="2">
+                  <c:v>1:1 Assekuranz</c:v>
+                </c:pt>
+                <c:pt idx="3">
+                  <c:v>vfm Service</c:v>
+                </c:pt>
+                <c:pt idx="4">
+                  <c:v>[pma:] Finanz- u. VM</c:v>
+                </c:pt>
+                <c:pt idx="5">
+                  <c:v>DEMA</c:v>
+                </c:pt>
+                <c:pt idx="6">
+                  <c:v>(ohne Pool)</c:v>
+                </c:pt>
+                <c:pt idx="7">
+                  <c:v>blau direkt</c:v>
+                </c:pt>
+                <c:pt idx="8">
                   <c:v>Fonds Finanz</c:v>
                 </c:pt>
-                <c:pt idx="2">
-                  <c:v>blau direkt</c:v>
-                </c:pt>
-                <c:pt idx="3">
-                  <c:v>(ohne Pool)</c:v>
-                </c:pt>
-                <c:pt idx="4">
-                  <c:v>DEMA</c:v>
-                </c:pt>
-                <c:pt idx="5">
-                  <c:v>[pma:] Finanz- u. VM</c:v>
-                </c:pt>
-                <c:pt idx="6">
-                  <c:v>vfm Service</c:v>
-                </c:pt>
-                <c:pt idx="7">
-                  <c:v>1:1 Assekuranz</c:v>
-                </c:pt>
-                <c:pt idx="8">
-                  <c:v>Securess</c:v>
-                </c:pt>
                 <c:pt idx="9">
-                  <c:v>Concordia</c:v>
+                  <c:v>JDC / Jung, DMS &amp; Cie.</c:v>
                 </c:pt>
               </c:strCache>
             </c:strRef>
@@ -542,34 +542,34 @@
                 <c:formatCode>General</c:formatCode>
                 <c:ptCount val="10"/>
                 <c:pt idx="0">
-                  <c:v>1538</c:v>
+                  <c:v>57</c:v>
                 </c:pt>
                 <c:pt idx="1">
+                  <c:v>70</c:v>
+                </c:pt>
+                <c:pt idx="2">
+                  <c:v>75</c:v>
+                </c:pt>
+                <c:pt idx="3">
+                  <c:v>75</c:v>
+                </c:pt>
+                <c:pt idx="4">
+                  <c:v>77</c:v>
+                </c:pt>
+                <c:pt idx="5">
+                  <c:v>114</c:v>
+                </c:pt>
+                <c:pt idx="6">
+                  <c:v>204</c:v>
+                </c:pt>
+                <c:pt idx="7">
+                  <c:v>255</c:v>
+                </c:pt>
+                <c:pt idx="8">
                   <c:v>612</c:v>
                 </c:pt>
-                <c:pt idx="2">
-                  <c:v>255</c:v>
-                </c:pt>
-                <c:pt idx="3">
-                  <c:v>204</c:v>
-                </c:pt>
-                <c:pt idx="4">
-                  <c:v>114</c:v>
-                </c:pt>
-                <c:pt idx="5">
-                  <c:v>77</c:v>
-                </c:pt>
-                <c:pt idx="6">
-                  <c:v>75</c:v>
-                </c:pt>
-                <c:pt idx="7">
-                  <c:v>75</c:v>
-                </c:pt>
-                <c:pt idx="8">
-                  <c:v>70</c:v>
-                </c:pt>
                 <c:pt idx="9">
-                  <c:v>57</c:v>
+                  <c:v>1538</c:v>
                 </c:pt>
               </c:numCache>
             </c:numRef>
@@ -598,7 +598,7 @@
           <c:showBubbleSize val="0"/>
           <c:showLeaderLines val="1"/>
         </c:dLbls>
-        <c:gapWidth val="50"/>
+        <c:gapWidth val="40"/>
         <c:axId val="-2068027336"/>
         <c:axId val="-2113994440"/>
       </c:barChart>
@@ -635,7 +635,7 @@
       <c:valAx>
         <c:axId val="-2113994440"/>
         <c:scaling>
-          <c:max val="1700.0"/>
+          <c:max val="1750.0"/>
         </c:scaling>
         <c:delete val="0"/>
         <c:axPos val="b"/>
@@ -3767,7 +3767,7 @@
                 </a:solidFill>
                 <a:latin typeface="Calibri"/>
               </a:rPr>
-              <a:t>5034 eingehende Mails | 94% in 1 Sammel-Postfach | Nur 79% sind echte neue Vorgaenge</a:t>
+              <a:t>5.034 Mails Eingang  -&gt;  4.000 davon sind BUe-Anfrage-Mails  -&gt;  Konsolidierung zu Vorgaengen siehe Slide 2</a:t>
             </a:r>
           </a:p>
         </p:txBody>
@@ -4240,7 +4240,7 @@
                 </a:solidFill>
                 <a:latin typeface="Calibri"/>
               </a:rPr>
-              <a:t>DAVON ECHTE NEUE BUe</a:t>
+              <a:t>DAVON BUe-ANFRAGE-MAILS</a:t>
             </a:r>
           </a:p>
         </p:txBody>
@@ -4310,7 +4310,7 @@
                 </a:solidFill>
                 <a:latin typeface="Calibri"/>
               </a:rPr>
-              <a:t>= 79,5 % - der Rest ist Triage-Aufwand</a:t>
+              <a:t>= 79,5 % der Mails  -  Rest = Triage-Aufwand</a:t>
             </a:r>
           </a:p>
         </p:txBody>
@@ -4479,7 +4479,7 @@
                 </a:solidFill>
                 <a:latin typeface="Calibri"/>
               </a:rPr>
-              <a:t>echte Neue BUe</a:t>
+              <a:t>BUe-Mails</a:t>
             </a:r>
           </a:p>
         </p:txBody>
@@ -4560,7 +4560,7 @@
                 </a:solidFill>
                 <a:latin typeface="Calibri"/>
               </a:rPr>
-              <a:t>2. SPARTEN-SPLIT der 4.000 Neue-BUe</a:t>
+              <a:t>2. SPARTEN-SPLIT der 4.000 BUe-Mails</a:t>
             </a:r>
           </a:p>
         </p:txBody>
@@ -4591,8 +4591,8 @@
         </p:nvSpPr>
         <p:spPr>
           <a:xfrm>
-            <a:off x="8275320" y="2971800"/>
-            <a:ext cx="3566160" cy="457200"/>
+            <a:off x="8275320" y="3063240"/>
+            <a:ext cx="3566160" cy="411480"/>
           </a:xfrm>
           <a:prstGeom prst="rect">
             <a:avLst/>
@@ -4607,7 +4607,7 @@
           <a:p>
             <a:pPr algn="ctr"/>
             <a:r>
-              <a:rPr sz="2400" b="1">
+              <a:rPr sz="2200" b="1">
                 <a:solidFill>
                   <a:srgbClr val="C8102E"/>
                 </a:solidFill>
@@ -4626,8 +4626,8 @@
         </p:nvSpPr>
         <p:spPr>
           <a:xfrm>
-            <a:off x="8275320" y="3383280"/>
-            <a:ext cx="3566160" cy="365760"/>
+            <a:off x="8275320" y="3429000"/>
+            <a:ext cx="3566160" cy="320040"/>
           </a:xfrm>
           <a:prstGeom prst="rect">
             <a:avLst/>
@@ -4642,13 +4642,13 @@
           <a:p>
             <a:pPr algn="ctr"/>
             <a:r>
-              <a:rPr sz="1100" b="0">
+              <a:rPr sz="1000" b="0">
                 <a:solidFill>
                   <a:srgbClr val="64748B"/>
                 </a:solidFill>
                 <a:latin typeface="Calibri"/>
               </a:rPr>
-              <a:t>Komposit dominiert</a:t>
+              <a:t>Komposit</a:t>
             </a:r>
           </a:p>
         </p:txBody>
@@ -4729,7 +4729,7 @@
                 </a:solidFill>
                 <a:latin typeface="Calibri"/>
               </a:rPr>
-              <a:t>TAKE-AWAY:  79,5 % echte Vorgaenge | 14 % falscher Kanal (705 Mails Triage-Aufwand) | Sparten-Mix Komposit &gt; KV &gt; Leben - KV mit 29 % ueberraschend stark</a:t>
+              <a:t>TAKE-AWAY:  79,5 % der Mails sind BUe-Anfragen | 14 % im falschen Kanal (705 Mails Triage-Aufwand) | Sparten-Mix Komposit &gt; KV &gt; Leben - KV mit 29 % ueberraschend stark</a:t>
             </a:r>
           </a:p>
         </p:txBody>
@@ -4825,7 +4825,7 @@
                 </a:solidFill>
                 <a:latin typeface="Calibri"/>
               </a:rPr>
-              <a:t>Vorgaenge &amp; Top-Makler - Mengen-Konzentration</a:t>
+              <a:t>Von Mails zu Vorgaengen - und wer die Mails schickt</a:t>
             </a:r>
           </a:p>
         </p:txBody>
@@ -4860,7 +4860,7 @@
                 </a:solidFill>
                 <a:latin typeface="Calibri"/>
               </a:rPr>
-              <a:t>4.000 Neue-BUe-Mails = nur 2.495 echte Vorgaenge | Top-10 Pools = 77 % des Volumens</a:t>
+              <a:t>4.000 BUe-Anfrage-Mails (von Slide 1) konsolidieren sich zu 2.495 echten Vorgaengen  |  Top-10 Pools = 77 % des Volumens</a:t>
             </a:r>
           </a:p>
         </p:txBody>
@@ -5089,7 +5089,7 @@
                 </a:solidFill>
                 <a:latin typeface="Calibri"/>
               </a:rPr>
-              <a:t>aus 4.000 Neue-BUe-Mails</a:t>
+              <a:t>aus 4.000 BUe-Anfrage-Mails  -38 %</a:t>
             </a:r>
           </a:p>
         </p:txBody>
@@ -5621,7 +5621,7 @@
                 </a:solidFill>
                 <a:latin typeface="Calibri"/>
               </a:rPr>
-              <a:t>TOP-10 MAKLERPOOLS (Neue-BUe-Mails / Woche)</a:t>
+              <a:t>TOP-10 MAKLERPOOLS (BUe-Anfrage-Mails pro Woche)</a:t>
             </a:r>
           </a:p>
         </p:txBody>

</xml_diff>